<commit_message>
lab(gpg): simplify game release to paired four-screenshot MVP
</commit_message>
<xml_diff>
--- a/labs/065-signed-game-release/assets/Game Release SUBMISSION TEMPLATE.pptx
+++ b/labs/065-signed-game-release/assets/Game Release SUBMISSION TEMPLATE.pptx
@@ -6882,8 +6882,8 @@
               <a:buNone/>
             </a:pPr>
             <a:r>
-              <a:rPr sz="2200"/>
-              <a:t>Screenshot 3 Trusted Developer Decrypts and Rebuilds</a:t>
+              <a:rPr sz="2400"/>
+              <a:t>Screenshot 3 Partner Source Decrypted</a:t>
             </a:r>
             <a:endParaRPr/>
           </a:p>
@@ -6983,8 +6983,8 @@
               <a:buNone/>
             </a:pPr>
             <a:r>
-              <a:rPr sz="2400"/>
-              <a:t>Screenshot 4 Player Cannot Decrypt the Source</a:t>
+              <a:rPr sz="2200"/>
+              <a:t>Screenshot 4 Sender Cannot Decrypt the Partner's Copy</a:t>
             </a:r>
             <a:endParaRPr/>
           </a:p>

</xml_diff>